<commit_message>
Make deck charts phone-safe and add a PDF export
- Spectrum chart (slide 2): linear axis with value labels instead of a
  logarithmic axis, which many mobile viewers draw incorrectly.
- Calibration chart (slide 4): each scatter series now carries only its
  own (x, y) points instead of a shared x list with blank y values, so
  viewers that pair points by position draw it correctly.
- Add Automated_Magnetics_Loss_Verification.pdf for viewing on phones.

Co-Authored-By: Claude Opus 5.5 <noreply@anthropic.com>
Claude-Session: https://claude.ai/code/session_01GajNLmvRADXqM9z3KQSzWS
</commit_message>
<xml_diff>
--- a/presentations/magnetics-loss-verification/Automated_Magnetics_Loss_Verification.pptx
+++ b/presentations/magnetics-loss-verification/Automated_Magnetics_Loss_Verification.pptx
@@ -112,24 +112,24 @@
   <p:extLst>
     <p:ext uri="{521415D9-36F7-43E2-AB2F-B90AF26B5E84}">
       <p14:sectionLst xmlns:p14="http://schemas.microsoft.com/office/powerpoint/2010/main">
-        <p14:section name="Concept" id="{f1d7cd6f-8f1e-fd8a-ae5a-01b885a9240b}">
+        <p14:section name="Concept" id="{aab4ab29-b7d3-ccff-d076-4650c6b7ce5c}">
           <p14:sldIdLst>
             <p14:sldId id="256"/>
           </p14:sldIdLst>
         </p14:section>
-        <p14:section name="Method" id="{f80998c0-7c03-da10-c654-a9df1ad86a6c}">
+        <p14:section name="Method" id="{4a85321e-5607-6322-a851-69271de7cbc6}">
           <p14:sldIdLst>
             <p14:sldId id="257"/>
             <p14:sldId id="258"/>
             <p14:sldId id="259"/>
           </p14:sldIdLst>
         </p14:section>
-        <p14:section name="Results" id="{0ff15a68-eba9-1394-8ad3-4df8b9fce1de}">
+        <p14:section name="Results" id="{2538288e-b24e-f9ec-1a6c-2bd9e3c3fed0}">
           <p14:sldIdLst>
             <p14:sldId id="260"/>
           </p14:sldIdLst>
         </p14:section>
-        <p14:section name="References" id="{07969268-78f6-37bc-b161-342f0d169292}">
+        <p14:section name="References" id="{05e1bf7f-a18f-a03c-891b-e84923a52724}">
           <p14:sldIdLst>
             <p14:sldId id="261"/>
           </p14:sldIdLst>
@@ -177,15 +177,15 @@
           </c:spPr>
           <c:invertIfNegative val="0"/>
           <c:dLbls>
-            <c:numFmt formatCode="#,##0" sourceLinked="0"/>
+            <c:numFmt formatCode="General" sourceLinked="0"/>
             <c:txPr>
               <a:bodyPr/>
               <a:lstStyle/>
               <a:p>
                 <a:pPr>
-                  <a:defRPr b="0" i="0" strike="noStrike" sz="1200" u="none">
+                  <a:defRPr b="0" i="0" strike="noStrike" sz="900" u="none">
                     <a:solidFill>
-                      <a:srgbClr val="000000"/>
+                      <a:srgbClr val="1E252B"/>
                     </a:solidFill>
                     <a:latin typeface="+mn-lt"/>
                   </a:defRPr>
@@ -193,7 +193,7 @@
               </a:p>
             </c:txPr>
             <c:showLegendKey val="0"/>
-            <c:showVal val="0"/>
+            <c:showVal val="1"/>
             <c:showCatName val="0"/>
             <c:showSerName val="0"/>
             <c:showPercent val="0"/>
@@ -281,15 +281,15 @@
           </c:val>
         </c:ser>
         <c:dLbls>
-          <c:numFmt formatCode="#,##0" sourceLinked="0"/>
+          <c:numFmt formatCode="General" sourceLinked="0"/>
           <c:txPr>
             <a:bodyPr/>
             <a:lstStyle/>
             <a:p>
               <a:pPr>
-                <a:defRPr b="0" i="0" strike="noStrike" sz="1200" u="none">
+                <a:defRPr b="0" i="0" strike="noStrike" sz="900" u="none">
                   <a:solidFill>
-                    <a:srgbClr val="000000"/>
+                    <a:srgbClr val="1E252B"/>
                   </a:solidFill>
                   <a:latin typeface="+mn-lt"/>
                 </a:defRPr>
@@ -297,7 +297,7 @@
             </a:p>
           </c:txPr>
           <c:showLegendKey val="0"/>
-          <c:showVal val="0"/>
+          <c:showVal val="1"/>
           <c:showCatName val="0"/>
           <c:showSerName val="0"/>
           <c:showPercent val="0"/>
@@ -383,10 +383,9 @@
       <c:valAx>
         <c:axId val="2094734552"/>
         <c:scaling>
-          <c:logBase val="10"/>
           <c:orientation val="minMax"/>
-          <c:max val="100"/>
-          <c:min val="0.1"/>
+          <c:max val="120"/>
+          <c:min val="0"/>
         </c:scaling>
         <c:delete val="0"/>
         <c:axPos val="l"/>
@@ -430,7 +429,7 @@
           <c:layout/>
           <c:overlay val="0"/>
         </c:title>
-        <c:numFmt formatCode="General" sourceLinked="0"/>
+        <c:numFmt formatCode="0" sourceLinked="0"/>
         <c:majorTickMark val="out"/>
         <c:minorTickMark val="none"/>
         <c:tickLblPos val="nextTo"/>
@@ -459,6 +458,7 @@
         <c:crossAx val="2094734554"/>
         <c:crosses val="autoZero"/>
         <c:crossBetween val="between"/>
+        <c:majorUnit val="20"/>
       </c:valAx>
       <c:spPr>
         <a:noFill/>
@@ -550,36 +550,24 @@
               <c:f>Sheet1!$A$2:$A$11</c:f>
               <c:numCache>
                 <c:formatCode>General</c:formatCode>
-                <c:ptCount val="10"/>
+                <c:ptCount val="6"/>
                 <c:pt idx="0">
-                  <c:v>0</c:v>
+                  <c:v>2</c:v>
                 </c:pt>
                 <c:pt idx="1">
-                  <c:v>2</c:v>
+                  <c:v>3</c:v>
                 </c:pt>
                 <c:pt idx="2">
-                  <c:v>3</c:v>
+                  <c:v>5</c:v>
                 </c:pt>
                 <c:pt idx="3">
-                  <c:v>5</c:v>
+                  <c:v>8</c:v>
                 </c:pt>
                 <c:pt idx="4">
-                  <c:v>6.6667</c:v>
+                  <c:v>10</c:v>
                 </c:pt>
                 <c:pt idx="5">
-                  <c:v>7.4</c:v>
-                </c:pt>
-                <c:pt idx="6">
-                  <c:v>8</c:v>
-                </c:pt>
-                <c:pt idx="7">
-                  <c:v>10</c:v>
-                </c:pt>
-                <c:pt idx="8">
                   <c:v>13</c:v>
-                </c:pt>
-                <c:pt idx="9">
-                  <c:v>14</c:v>
                 </c:pt>
               </c:numCache>
             </c:numRef>
@@ -589,23 +577,23 @@
               <c:f>Sheet1!$B$2:$B$11</c:f>
               <c:numCache>
                 <c:formatCode>General</c:formatCode>
-                <c:ptCount val="10"/>
-                <c:pt idx="1">
+                <c:ptCount val="6"/>
+                <c:pt idx="0">
                   <c:v>0.1538</c:v>
                 </c:pt>
-                <c:pt idx="2">
+                <c:pt idx="1">
                   <c:v>0.2308</c:v>
                 </c:pt>
-                <c:pt idx="3">
+                <c:pt idx="2">
                   <c:v>0.3846</c:v>
                 </c:pt>
-                <c:pt idx="6">
+                <c:pt idx="3">
                   <c:v>0.6154</c:v>
                 </c:pt>
-                <c:pt idx="7">
+                <c:pt idx="4">
                   <c:v>0.7692</c:v>
                 </c:pt>
-                <c:pt idx="8">
+                <c:pt idx="5">
                   <c:v>1</c:v>
                 </c:pt>
               </c:numCache>
@@ -648,35 +636,11 @@
               <c:f>Sheet1!$A$2:$A$11</c:f>
               <c:numCache>
                 <c:formatCode>General</c:formatCode>
-                <c:ptCount val="10"/>
+                <c:ptCount val="2"/>
                 <c:pt idx="0">
                   <c:v>0</c:v>
                 </c:pt>
                 <c:pt idx="1">
-                  <c:v>2</c:v>
-                </c:pt>
-                <c:pt idx="2">
-                  <c:v>3</c:v>
-                </c:pt>
-                <c:pt idx="3">
-                  <c:v>5</c:v>
-                </c:pt>
-                <c:pt idx="4">
-                  <c:v>6.6667</c:v>
-                </c:pt>
-                <c:pt idx="5">
-                  <c:v>7.4</c:v>
-                </c:pt>
-                <c:pt idx="6">
-                  <c:v>8</c:v>
-                </c:pt>
-                <c:pt idx="7">
-                  <c:v>10</c:v>
-                </c:pt>
-                <c:pt idx="8">
-                  <c:v>13</c:v>
-                </c:pt>
-                <c:pt idx="9">
                   <c:v>14</c:v>
                 </c:pt>
               </c:numCache>
@@ -687,11 +651,11 @@
               <c:f>Sheet1!$C$2:$C$11</c:f>
               <c:numCache>
                 <c:formatCode>General</c:formatCode>
-                <c:ptCount val="10"/>
+                <c:ptCount val="2"/>
                 <c:pt idx="0">
                   <c:v>0</c:v>
                 </c:pt>
-                <c:pt idx="9">
+                <c:pt idx="1">
                   <c:v>1.0769</c:v>
                 </c:pt>
               </c:numCache>
@@ -744,36 +708,12 @@
               <c:f>Sheet1!$A$2:$A$11</c:f>
               <c:numCache>
                 <c:formatCode>General</c:formatCode>
-                <c:ptCount val="10"/>
+                <c:ptCount val="2"/>
                 <c:pt idx="0">
-                  <c:v>0</c:v>
+                  <c:v>6.6667</c:v>
                 </c:pt>
                 <c:pt idx="1">
-                  <c:v>2</c:v>
-                </c:pt>
-                <c:pt idx="2">
-                  <c:v>3</c:v>
-                </c:pt>
-                <c:pt idx="3">
-                  <c:v>5</c:v>
-                </c:pt>
-                <c:pt idx="4">
-                  <c:v>6.6667</c:v>
-                </c:pt>
-                <c:pt idx="5">
                   <c:v>7.4</c:v>
-                </c:pt>
-                <c:pt idx="6">
-                  <c:v>8</c:v>
-                </c:pt>
-                <c:pt idx="7">
-                  <c:v>10</c:v>
-                </c:pt>
-                <c:pt idx="8">
-                  <c:v>13</c:v>
-                </c:pt>
-                <c:pt idx="9">
-                  <c:v>14</c:v>
                 </c:pt>
               </c:numCache>
             </c:numRef>
@@ -783,11 +723,11 @@
               <c:f>Sheet1!$D$2:$D$11</c:f>
               <c:numCache>
                 <c:formatCode>General</c:formatCode>
-                <c:ptCount val="10"/>
-                <c:pt idx="4">
+                <c:ptCount val="2"/>
+                <c:pt idx="0">
                   <c:v>0.5128</c:v>
                 </c:pt>
-                <c:pt idx="5">
+                <c:pt idx="1">
                   <c:v>0.5692</c:v>
                 </c:pt>
               </c:numCache>
@@ -4800,7 +4740,7 @@
       </p:sp>
       <p:graphicFrame>
         <p:nvGraphicFramePr>
-          <p:cNvPr id="30" name="FFT spectrum chart" descr="Logarithmic bar chart of the ten sinusoidal source amplitudes of a triangular 400 kHz ripple current: 100 % at 0.4 MHz, 11 % at 1.2 MHz, 4 % at 2.0 MHz, falling to 0.3 % at 7.6 MHz."/>
+          <p:cNvPr id="30" name="FFT spectrum chart" descr="Bar chart of the ten sinusoidal source amplitudes of a triangular 400 kHz ripple current: 100 % at 0.4 MHz, 11 % at 1.2 MHz, 4 % at 2.0 MHz, falling to 0.3 % at 7.6 MHz."/>
           <p:cNvGraphicFramePr/>
           <p:nvPr/>
         </p:nvGraphicFramePr>

</xml_diff>